<commit_message>
docs: preserve final study presentation
</commit_message>
<xml_diff>
--- a/doc/study-documentation/dapi_presentation.pptx
+++ b/doc/study-documentation/dapi_presentation.pptx
@@ -463,7 +463,7 @@
           <a:p>
             <a:fld id="{37A2730A-859E-B540-ADF3-E97069AD1FDB}" type="datetimeFigureOut">
               <a:rPr lang="en-US" smtClean="0"/>
-              <a:t>6/23/26</a:t>
+              <a:t>6/24/26</a:t>
             </a:fld>
             <a:endParaRPr lang="en-US"/>
           </a:p>
@@ -661,7 +661,7 @@
           <a:p>
             <a:fld id="{37A2730A-859E-B540-ADF3-E97069AD1FDB}" type="datetimeFigureOut">
               <a:rPr lang="en-US" smtClean="0"/>
-              <a:t>6/23/26</a:t>
+              <a:t>6/24/26</a:t>
             </a:fld>
             <a:endParaRPr lang="en-US"/>
           </a:p>
@@ -869,7 +869,7 @@
           <a:p>
             <a:fld id="{37A2730A-859E-B540-ADF3-E97069AD1FDB}" type="datetimeFigureOut">
               <a:rPr lang="en-US" smtClean="0"/>
-              <a:t>6/23/26</a:t>
+              <a:t>6/24/26</a:t>
             </a:fld>
             <a:endParaRPr lang="en-US"/>
           </a:p>
@@ -1067,7 +1067,7 @@
           <a:p>
             <a:fld id="{37A2730A-859E-B540-ADF3-E97069AD1FDB}" type="datetimeFigureOut">
               <a:rPr lang="en-US" smtClean="0"/>
-              <a:t>6/23/26</a:t>
+              <a:t>6/24/26</a:t>
             </a:fld>
             <a:endParaRPr lang="en-US"/>
           </a:p>
@@ -1342,7 +1342,7 @@
           <a:p>
             <a:fld id="{37A2730A-859E-B540-ADF3-E97069AD1FDB}" type="datetimeFigureOut">
               <a:rPr lang="en-US" smtClean="0"/>
-              <a:t>6/23/26</a:t>
+              <a:t>6/24/26</a:t>
             </a:fld>
             <a:endParaRPr lang="en-US"/>
           </a:p>
@@ -1607,7 +1607,7 @@
           <a:p>
             <a:fld id="{37A2730A-859E-B540-ADF3-E97069AD1FDB}" type="datetimeFigureOut">
               <a:rPr lang="en-US" smtClean="0"/>
-              <a:t>6/23/26</a:t>
+              <a:t>6/24/26</a:t>
             </a:fld>
             <a:endParaRPr lang="en-US"/>
           </a:p>
@@ -2019,7 +2019,7 @@
           <a:p>
             <a:fld id="{37A2730A-859E-B540-ADF3-E97069AD1FDB}" type="datetimeFigureOut">
               <a:rPr lang="en-US" smtClean="0"/>
-              <a:t>6/23/26</a:t>
+              <a:t>6/24/26</a:t>
             </a:fld>
             <a:endParaRPr lang="en-US"/>
           </a:p>
@@ -2160,7 +2160,7 @@
           <a:p>
             <a:fld id="{37A2730A-859E-B540-ADF3-E97069AD1FDB}" type="datetimeFigureOut">
               <a:rPr lang="en-US" smtClean="0"/>
-              <a:t>6/23/26</a:t>
+              <a:t>6/24/26</a:t>
             </a:fld>
             <a:endParaRPr lang="en-US"/>
           </a:p>
@@ -2273,7 +2273,7 @@
           <a:p>
             <a:fld id="{37A2730A-859E-B540-ADF3-E97069AD1FDB}" type="datetimeFigureOut">
               <a:rPr lang="en-US" smtClean="0"/>
-              <a:t>6/23/26</a:t>
+              <a:t>6/24/26</a:t>
             </a:fld>
             <a:endParaRPr lang="en-US"/>
           </a:p>
@@ -2584,7 +2584,7 @@
           <a:p>
             <a:fld id="{37A2730A-859E-B540-ADF3-E97069AD1FDB}" type="datetimeFigureOut">
               <a:rPr lang="en-US" smtClean="0"/>
-              <a:t>6/23/26</a:t>
+              <a:t>6/24/26</a:t>
             </a:fld>
             <a:endParaRPr lang="en-US"/>
           </a:p>
@@ -2872,7 +2872,7 @@
           <a:p>
             <a:fld id="{37A2730A-859E-B540-ADF3-E97069AD1FDB}" type="datetimeFigureOut">
               <a:rPr lang="en-US" smtClean="0"/>
-              <a:t>6/23/26</a:t>
+              <a:t>6/24/26</a:t>
             </a:fld>
             <a:endParaRPr lang="en-US"/>
           </a:p>
@@ -3116,7 +3116,7 @@
           <a:p>
             <a:fld id="{37A2730A-859E-B540-ADF3-E97069AD1FDB}" type="datetimeFigureOut">
               <a:rPr lang="en-US" smtClean="0"/>
-              <a:t>6/23/26</a:t>
+              <a:t>6/24/26</a:t>
             </a:fld>
             <a:endParaRPr lang="en-US"/>
           </a:p>
@@ -4318,7 +4318,7 @@
                   <a:srgbClr val="171717"/>
                 </a:solidFill>
               </a:rPr>
-              <a:t>SW-UART (PA6) statt HW-USART1 · falscher Pin in 1. PCB-Revision</a:t>
+              <a:t>SW-UART (PA6) statt HW-USART1, falscher Pin in 1. PCB-Revision</a:t>
             </a:r>
           </a:p>
           <a:p>
@@ -4358,7 +4358,7 @@
                   <a:srgbClr val="171717"/>
                 </a:solidFill>
               </a:rPr>
-              <a:t>Asynchrone Pre-Measurement-Timer (SCD41 5,5 s · SPS30 16,5 s)</a:t>
+              <a:t>Asynchrone Pre-Measurement-Timer (SCD41 5,5 s &amp; SPS30 16,5 s)</a:t>
             </a:r>
           </a:p>
           <a:p>
@@ -4439,7 +4439,27 @@
                   <a:srgbClr val="171717"/>
                 </a:solidFill>
               </a:rPr>
-              <a:t>PCB-Aufwand 9 h -&gt; 56 h: kein OSS-Design für STM32WLE5</a:t>
+              <a:t>PCB-Aufwand 9 h -&gt; 56 h: kein </a:t>
+            </a:r>
+            <a:r>
+              <a:rPr lang="de-DE" sz="1500" dirty="0"/>
+              <a:t>Fertiges </a:t>
+            </a:r>
+            <a:r>
+              <a:rPr lang="de-DE" sz="1500" dirty="0" err="1"/>
+              <a:t>Desgin</a:t>
+            </a:r>
+            <a:r>
+              <a:rPr lang="de-DE" sz="1500" dirty="0"/>
+              <a:t> </a:t>
+            </a:r>
+            <a:r>
+              <a:rPr lang="de-DE" sz="1500" dirty="0">
+                <a:solidFill>
+                  <a:srgbClr val="171717"/>
+                </a:solidFill>
+              </a:rPr>
+              <a:t>für den STM32WLE5</a:t>
             </a:r>
           </a:p>
           <a:p>
@@ -4459,7 +4479,22 @@
                   <a:srgbClr val="171717"/>
                 </a:solidFill>
               </a:rPr>
-              <a:t>TPS63900 Step-up/down-Wandler defekt -&gt; Breakout-Workaround</a:t>
+              <a:t>TPS63900 Step-up/down-Wandler falsch konfiguriert </a:t>
+            </a:r>
+            <a:br>
+              <a:rPr lang="de-DE" sz="1500" dirty="0">
+                <a:solidFill>
+                  <a:srgbClr val="171717"/>
+                </a:solidFill>
+              </a:rPr>
+            </a:br>
+            <a:r>
+              <a:rPr lang="de-DE" sz="1500" dirty="0">
+                <a:solidFill>
+                  <a:srgbClr val="171717"/>
+                </a:solidFill>
+              </a:rPr>
+              <a:t>-&gt; Breakout-Workaround</a:t>
             </a:r>
           </a:p>
           <a:p>
@@ -4479,7 +4514,7 @@
                   <a:srgbClr val="171717"/>
                 </a:solidFill>
               </a:rPr>
-              <a:t>BQ25185: interner 6 h Safety-Timer beendet Laden -&gt; Reset per GPIO-CE (200 ms HIGH pro Messung)</a:t>
+              <a:t>BQ25185: interner 6 h Safety-Timer beendet Laden -&gt; Reset per GPIO-CE (200 ms HIGH pro 2h)</a:t>
             </a:r>
           </a:p>
           <a:p>
@@ -4499,7 +4534,7 @@
                   <a:srgbClr val="171717"/>
                 </a:solidFill>
               </a:rPr>
-              <a:t>Sensor-Wechsel: BME280 -&gt; SHT45+BMP390 · VEML6075 -&gt; LTR390 · MAX4466 entfällt</a:t>
+              <a:t>Sensor-Wechsel: BME280 -&gt; SHT45+BMP390 &amp; VEML6075 -&gt; LTR390</a:t>
             </a:r>
           </a:p>
           <a:p>
@@ -4520,6 +4555,26 @@
                 </a:solidFill>
               </a:rPr>
               <a:t>UV-Fenster: 2 mm Polystyrol + Korrekturfaktor 17/13</a:t>
+            </a:r>
+          </a:p>
+          <a:p>
+            <a:pPr marL="274320" indent="-274320">
+              <a:spcBef>
+                <a:spcPts val="900"/>
+              </a:spcBef>
+              <a:buClr>
+                <a:srgbClr val="0070F3"/>
+              </a:buClr>
+              <a:buFont typeface="Arial"/>
+              <a:buChar char="•"/>
+            </a:pPr>
+            <a:r>
+              <a:rPr lang="de-DE" sz="1500" dirty="0">
+                <a:solidFill>
+                  <a:srgbClr val="171717"/>
+                </a:solidFill>
+              </a:rPr>
+              <a:t>Reichweite bei TTN und an der OTH</a:t>
             </a:r>
           </a:p>
         </p:txBody>
@@ -4603,7 +4658,7 @@
                   <a:srgbClr val="000000"/>
                 </a:solidFill>
               </a:rPr>
-              <a:t>Das System läuft.</a:t>
+              <a:t>Fazit</a:t>
             </a:r>
           </a:p>
         </p:txBody>
@@ -4670,7 +4725,7 @@
                   <a:srgbClr val="171717"/>
                 </a:solidFill>
               </a:rPr>
-              <a:t>Alle 5 Kernsensoren liefern stabile Feldtest-Daten · Pipeline funktioniert end-to-end</a:t>
+              <a:t>Alle 5 Kernsensoren liefern stabile Feldtest-Daten; Pipeline funktioniert end-to-end</a:t>
             </a:r>
           </a:p>
           <a:p>
@@ -4690,7 +4745,7 @@
                   <a:srgbClr val="171717"/>
                 </a:solidFill>
               </a:rPr>
-              <a:t>Größter Lerneffekt: PCB-Design (9 h -&gt; 56 h) · RF, 4-Lagen-Stackup, Antennenpfad</a:t>
+              <a:t>Größter Lerneffekt: PCB-Design (9 h -&gt; 56 h); RF, 4-Lagen-Stackup, Antennenpfad</a:t>
             </a:r>
           </a:p>
           <a:p>
@@ -4712,6 +4767,27 @@
               </a:rPr>
               <a:t>Bugs (TPS63900, SW-UART, BQ25185-Solar-Timeout) als lehrreichste Momente</a:t>
             </a:r>
+          </a:p>
+          <a:p>
+            <a:pPr marL="342900" indent="-342900">
+              <a:spcBef>
+                <a:spcPts val="1100"/>
+              </a:spcBef>
+              <a:buClr>
+                <a:srgbClr val="0070F3"/>
+              </a:buClr>
+              <a:buFont typeface="Arial"/>
+              <a:buChar char="•"/>
+            </a:pPr>
+            <a:r>
+              <a:rPr lang="de-DE" sz="1800" dirty="0"/>
+              <a:t>Anfrage beim Green-Office für OTH als Location</a:t>
+            </a:r>
+            <a:endParaRPr lang="de-DE" sz="1800" dirty="0">
+              <a:solidFill>
+                <a:srgbClr val="171717"/>
+              </a:solidFill>
+            </a:endParaRPr>
           </a:p>
           <a:p>
             <a:pPr>
@@ -5386,6 +5462,67 @@
           </a:p>
         </p:txBody>
       </p:sp>
+      <p:pic>
+        <p:nvPicPr>
+          <p:cNvPr id="5" name="Grafik 4" descr="Wio-E5 LoRaWAN Mini Dev Board with STM32WLE5JC 113990939 Antratek Electronics">
+            <a:extLst>
+              <a:ext uri="{FF2B5EF4-FFF2-40B4-BE49-F238E27FC236}">
+                <a16:creationId xmlns:a16="http://schemas.microsoft.com/office/drawing/2014/main" id="{664239A1-4246-6042-7D23-2A573F8D5C3D}"/>
+              </a:ext>
+            </a:extLst>
+          </p:cNvPr>
+          <p:cNvPicPr>
+            <a:picLocks noChangeAspect="1"/>
+          </p:cNvPicPr>
+          <p:nvPr/>
+        </p:nvPicPr>
+        <p:blipFill>
+          <a:blip r:embed="rId2"/>
+          <a:stretch>
+            <a:fillRect/>
+          </a:stretch>
+        </p:blipFill>
+        <p:spPr>
+          <a:xfrm>
+            <a:off x="1782745" y="4360147"/>
+            <a:ext cx="2497853" cy="2497853"/>
+          </a:xfrm>
+          <a:prstGeom prst="rect">
+            <a:avLst/>
+          </a:prstGeom>
+        </p:spPr>
+      </p:pic>
+      <p:pic>
+        <p:nvPicPr>
+          <p:cNvPr id="7" name="Grafik 6" descr="pcb_routing.png">
+            <a:extLst>
+              <a:ext uri="{FF2B5EF4-FFF2-40B4-BE49-F238E27FC236}">
+                <a16:creationId xmlns:a16="http://schemas.microsoft.com/office/drawing/2014/main" id="{4AFFEA79-D6A6-4098-EFC1-67D6A87641BF}"/>
+              </a:ext>
+            </a:extLst>
+          </p:cNvPr>
+          <p:cNvPicPr>
+            <a:picLocks noChangeAspect="1"/>
+          </p:cNvPicPr>
+          <p:nvPr/>
+        </p:nvPicPr>
+        <p:blipFill>
+          <a:blip r:embed="rId3"/>
+          <a:srcRect l="6442" t="1879" r="5474" b="10274"/>
+          <a:stretch>
+            <a:fillRect/>
+          </a:stretch>
+        </p:blipFill>
+        <p:spPr>
+          <a:xfrm>
+            <a:off x="6964345" y="4519449"/>
+            <a:ext cx="3084844" cy="2179247"/>
+          </a:xfrm>
+          <a:prstGeom prst="rect">
+            <a:avLst/>
+          </a:prstGeom>
+        </p:spPr>
+      </p:pic>
     </p:spTree>
     <p:extLst>
       <p:ext uri="{BB962C8B-B14F-4D97-AF65-F5344CB8AC3E}">
@@ -5489,7 +5626,7 @@
         <p:spPr>
           <a:xfrm>
             <a:off x="838200" y="2028825"/>
-            <a:ext cx="10515600" cy="4351338"/>
+            <a:ext cx="6674708" cy="4351338"/>
           </a:xfrm>
         </p:spPr>
         <p:txBody>
@@ -5617,6 +5754,36 @@
           </a:p>
         </p:txBody>
       </p:sp>
+      <p:pic>
+        <p:nvPicPr>
+          <p:cNvPr id="4" name="Grafik 3" descr="stevenson_render.png">
+            <a:extLst>
+              <a:ext uri="{FF2B5EF4-FFF2-40B4-BE49-F238E27FC236}">
+                <a16:creationId xmlns:a16="http://schemas.microsoft.com/office/drawing/2014/main" id="{149B8A2C-993E-0A18-C7C0-F621D07F3517}"/>
+              </a:ext>
+            </a:extLst>
+          </p:cNvPr>
+          <p:cNvPicPr>
+            <a:picLocks noChangeAspect="1"/>
+          </p:cNvPicPr>
+          <p:nvPr/>
+        </p:nvPicPr>
+        <p:blipFill>
+          <a:blip r:embed="rId2"/>
+          <a:stretch>
+            <a:fillRect/>
+          </a:stretch>
+        </p:blipFill>
+        <p:spPr>
+          <a:xfrm>
+            <a:off x="7905883" y="1893888"/>
+            <a:ext cx="3820680" cy="3812786"/>
+          </a:xfrm>
+          <a:prstGeom prst="rect">
+            <a:avLst/>
+          </a:prstGeom>
+        </p:spPr>
+      </p:pic>
     </p:spTree>
     <p:extLst>
       <p:ext uri="{BB962C8B-B14F-4D97-AF65-F5344CB8AC3E}">
@@ -5757,7 +5924,30 @@
                   <a:srgbClr val="171717"/>
                 </a:solidFill>
               </a:rPr>
-              <a:t>CMake + ARM GCC, zweigleisig: Debug (Wio-E5, -O0 -g3) &amp; Release (Custom PCB, -Os)</a:t>
+              <a:t>CMake + ARM GCC, zweigleisig: </a:t>
+            </a:r>
+            <a:br>
+              <a:rPr lang="de-DE" sz="1600" dirty="0">
+                <a:solidFill>
+                  <a:srgbClr val="171717"/>
+                </a:solidFill>
+              </a:rPr>
+            </a:br>
+            <a:r>
+              <a:rPr lang="de-DE" sz="1600" dirty="0" err="1">
+                <a:solidFill>
+                  <a:srgbClr val="171717"/>
+                </a:solidFill>
+              </a:rPr>
+              <a:t>Debug</a:t>
+            </a:r>
+            <a:r>
+              <a:rPr lang="de-DE" sz="1600" dirty="0">
+                <a:solidFill>
+                  <a:srgbClr val="171717"/>
+                </a:solidFill>
+              </a:rPr>
+              <a:t> (Wio-E5) &amp; Release (Custom PCB)</a:t>
             </a:r>
           </a:p>
           <a:p>
@@ -5939,7 +6129,7 @@
                   <a:srgbClr val="171717"/>
                 </a:solidFill>
               </a:rPr>
-              <a:t>STOP2-Schlaf nach jedem Engine-Lauf, Weckung per RTC-Alarm</a:t>
+              <a:t>STOP2-Schlaf nach jedem Engine-Lauf</a:t>
             </a:r>
           </a:p>
           <a:p>
@@ -7610,7 +7800,7 @@
                   <a:srgbClr val="171717"/>
                 </a:solidFill>
               </a:rPr>
-              <a:t>LoRaWAN -&gt; Netzwerk-Server (Helium · ChirpStack v4 · TTN) -&gt; Webhook   |   HTTPS · TLS 1.2+ · HMAC-SHA256</a:t>
+              <a:t>LoRaWAN -&gt; Netzwerk-Server (Helium · TTN) -&gt; Webhook   |   HTTPS · TLS 1.2+ · HMAC-SHA256</a:t>
             </a:r>
           </a:p>
         </p:txBody>
@@ -8123,6 +8313,15 @@
 </file>
 
 <file path=customXml/item1.xml><?xml version="1.0" encoding="utf-8"?>
+<?mso-contentType ?>
+<FormTemplates xmlns="http://schemas.microsoft.com/sharepoint/v3/contenttype/forms">
+  <Display>DocumentLibraryForm</Display>
+  <Edit>DocumentLibraryForm</Edit>
+  <New>DocumentLibraryForm</New>
+</FormTemplates>
+</file>
+
+<file path=customXml/item2.xml><?xml version="1.0" encoding="utf-8"?>
 <ct:contentTypeSchema xmlns:ct="http://schemas.microsoft.com/office/2006/metadata/contentType" xmlns:ma="http://schemas.microsoft.com/office/2006/metadata/properties/metaAttributes" ct:_="" ma:_="" ma:contentTypeName="Document" ma:contentTypeID="0x010100CD401524DC532D42A0E0ED886331A72B" ma:contentTypeVersion="13" ma:contentTypeDescription="Create a new document." ma:contentTypeScope="" ma:versionID="d936d863d335d354da51eb78ca1ae338">
   <xsd:schema xmlns:xsd="http://www.w3.org/2001/XMLSchema" xmlns:xs="http://www.w3.org/2001/XMLSchema" xmlns:p="http://schemas.microsoft.com/office/2006/metadata/properties" xmlns:ns2="f577acbf-5b0b-4b4f-9948-268e97f8d3a4" xmlns:ns3="b1e4d6ee-9f6f-43f8-a618-24f3d84da28f" targetNamespace="http://schemas.microsoft.com/office/2006/metadata/properties" ma:root="true" ma:fieldsID="5fbac08d56b1b04aa33acbc31e882ce9" ns2:_="" ns3:_="">
     <xsd:import namespace="f577acbf-5b0b-4b4f-9948-268e97f8d3a4"/>
@@ -8366,15 +8565,6 @@
 </ct:contentTypeSchema>
 </file>
 
-<file path=customXml/item2.xml><?xml version="1.0" encoding="utf-8"?>
-<?mso-contentType ?>
-<FormTemplates xmlns="http://schemas.microsoft.com/sharepoint/v3/contenttype/forms">
-  <Display>DocumentLibraryForm</Display>
-  <Edit>DocumentLibraryForm</Edit>
-  <New>DocumentLibraryForm</New>
-</FormTemplates>
-</file>
-
 <file path=customXml/item3.xml><?xml version="1.0" encoding="utf-8"?>
 <p:properties xmlns:p="http://schemas.microsoft.com/office/2006/metadata/properties" xmlns:xsi="http://www.w3.org/2001/XMLSchema-instance" xmlns:pc="http://schemas.microsoft.com/office/infopath/2007/PartnerControls">
   <documentManagement>
@@ -8385,6 +8575,14 @@
 </file>
 
 <file path=customXml/itemProps1.xml><?xml version="1.0" encoding="utf-8"?>
+<ds:datastoreItem xmlns:ds="http://schemas.openxmlformats.org/officeDocument/2006/customXml" ds:itemID="{E21AFCC0-734A-4A90-A597-A1CB34860DCD}">
+  <ds:schemaRefs>
+    <ds:schemaRef ds:uri="http://schemas.microsoft.com/sharepoint/v3/contenttype/forms"/>
+  </ds:schemaRefs>
+</ds:datastoreItem>
+</file>
+
+<file path=customXml/itemProps2.xml><?xml version="1.0" encoding="utf-8"?>
 <ds:datastoreItem xmlns:ds="http://schemas.openxmlformats.org/officeDocument/2006/customXml" ds:itemID="{A79EAE08-AAD0-49B9-BF66-164C225CC523}">
   <ds:schemaRefs>
     <ds:schemaRef ds:uri="http://schemas.microsoft.com/office/2006/metadata/contentType"/>
@@ -8399,14 +8597,6 @@
     <ds:schemaRef ds:uri="http://purl.org/dc/elements/1.1/"/>
     <ds:schemaRef ds:uri="http://purl.org/dc/terms/"/>
     <ds:schemaRef ds:uri="http://schemas.microsoft.com/internal/obd"/>
-  </ds:schemaRefs>
-</ds:datastoreItem>
-</file>
-
-<file path=customXml/itemProps2.xml><?xml version="1.0" encoding="utf-8"?>
-<ds:datastoreItem xmlns:ds="http://schemas.openxmlformats.org/officeDocument/2006/customXml" ds:itemID="{E21AFCC0-734A-4A90-A597-A1CB34860DCD}">
-  <ds:schemaRefs>
-    <ds:schemaRef ds:uri="http://schemas.microsoft.com/sharepoint/v3/contenttype/forms"/>
   </ds:schemaRefs>
 </ds:datastoreItem>
 </file>

</xml_diff>